<commit_message>
feat: embed real Double Coverage Campaign Auto-Clipper dashboard screenshot into Slide 7 and website data
</commit_message>
<xml_diff>
--- a/assets/docs/Biru_Putih_Portofolio_Presentasi.pptx
+++ b/assets/docs/Biru_Putih_Portofolio_Presentasi.pptx
@@ -10619,7 +10619,7 @@
                 </a:solidFill>
                 <a:latin typeface="Segoe UI"/>
               </a:rPr>
-              <a:t>Autonomous Multi-Agent AI Video Pipeline</a:t>
+              <a:t>Double Coverage Auto-Clipper: Multi-Agent Video Pipeline</a:t>
             </a:r>
           </a:p>
         </p:txBody>
@@ -10667,7 +10667,7 @@
                 </a:solidFill>
                 <a:latin typeface="Segoe UI"/>
               </a:rPr>
-              <a:t>Orkestrasi agen otonom dengan Google Antigravity untuk kurasi &amp; rendering video pendek berkecepatan tinggi.</a:t>
+              <a:t>Sistem otomasi alur kerja cerdas untuk kurasi momen viral dan batch rendering video vertikal 9:16.</a:t>
             </a:r>
           </a:p>
         </p:txBody>
@@ -10681,11 +10681,11 @@
         <p:spPr>
           <a:xfrm>
             <a:off x="731520" y="1691640"/>
-            <a:ext cx="3383280" cy="868680"/>
+            <a:ext cx="6217920" cy="4709160"/>
           </a:xfrm>
           <a:prstGeom prst="roundRect">
             <a:avLst>
-              <a:gd name="adj" fmla="val 3000"/>
+              <a:gd name="adj" fmla="val 2000"/>
             </a:avLst>
           </a:prstGeom>
           <a:solidFill>
@@ -10719,56 +10719,52 @@
           </a:p>
         </p:txBody>
       </p:sp>
-      <p:sp>
-        <p:nvSpPr>
-          <p:cNvPr id="7" name="TextBox 6"/>
-          <p:cNvSpPr txBox="1"/>
-          <p:nvPr/>
-        </p:nvSpPr>
-        <p:spPr>
-          <a:xfrm>
-            <a:off x="868680" y="1755648"/>
-            <a:ext cx="3108960" cy="731520"/>
+      <p:pic>
+        <p:nvPicPr>
+          <p:cNvPr id="7" name="Picture 6" descr="project-ai-automation.png"/>
+          <p:cNvPicPr>
+            <a:picLocks noChangeAspect="1"/>
+          </p:cNvPicPr>
+          <p:nvPr/>
+        </p:nvPicPr>
+        <p:blipFill>
+          <a:blip r:embed="rId2"/>
+          <a:stretch>
+            <a:fillRect/>
+          </a:stretch>
+        </p:blipFill>
+        <p:spPr>
+          <a:xfrm>
+            <a:off x="868680" y="1828800"/>
+            <a:ext cx="5943600" cy="4069080"/>
           </a:xfrm>
           <a:prstGeom prst="rect">
             <a:avLst/>
           </a:prstGeom>
+        </p:spPr>
+      </p:pic>
+      <p:sp>
+        <p:nvSpPr>
+          <p:cNvPr id="8" name="TextBox 7"/>
+          <p:cNvSpPr txBox="1"/>
+          <p:nvPr/>
+        </p:nvSpPr>
+        <p:spPr>
+          <a:xfrm>
+            <a:off x="868680" y="5961888"/>
+            <a:ext cx="5943600" cy="347472"/>
+          </a:xfrm>
+          <a:prstGeom prst="rect">
+            <a:avLst/>
+          </a:prstGeom>
           <a:noFill/>
         </p:spPr>
         <p:txBody>
-          <a:bodyPr wrap="square" lIns="0" tIns="0">
+          <a:bodyPr wrap="none" lIns="0" tIns="0">
             <a:spAutoFit/>
           </a:bodyPr>
           <a:lstStyle/>
           <a:p>
-            <a:pPr>
-              <a:defRPr sz="1700" b="1">
-                <a:solidFill>
-                  <a:srgbClr val="2563EB"/>
-                </a:solidFill>
-                <a:latin typeface="Segoe UI"/>
-              </a:defRPr>
-            </a:pPr>
-            <a:r>
-              <a:rPr sz="1700" b="1">
-                <a:solidFill>
-                  <a:srgbClr val="2563EB"/>
-                </a:solidFill>
-                <a:latin typeface="Segoe UI"/>
-              </a:rPr>
-              <a:t>~70% </a:t>
-            </a:r>
-            <a:r>
-              <a:rPr sz="950" b="1">
-                <a:solidFill>
-                  <a:srgbClr val="0F2437"/>
-                </a:solidFill>
-                <a:latin typeface="Segoe UI"/>
-              </a:rPr>
-              <a:t> REDUKSI TURNAROUND</a:t>
-            </a:r>
-          </a:p>
-          <a:p>
             <a:pPr algn="l">
               <a:spcBef>
                 <a:spcPts val="0"/>
@@ -10776,7 +10772,7 @@
               <a:spcAft>
                 <a:spcPts val="300"/>
               </a:spcAft>
-              <a:defRPr sz="800" b="0" i="0">
+              <a:defRPr sz="850" b="0" i="1">
                 <a:solidFill>
                   <a:srgbClr val="475569"/>
                 </a:solidFill>
@@ -10784,31 +10780,31 @@
               </a:defRPr>
             </a:pPr>
             <a:r>
-              <a:rPr sz="800" b="0" i="0">
+              <a:rPr sz="850" b="0" i="1">
                 <a:solidFill>
                   <a:srgbClr val="475569"/>
                 </a:solidFill>
                 <a:latin typeface="Segoe UI"/>
               </a:rPr>
-              <a:t>Penyusutan waktu dari transkrip mentah ke video siap tayang.</a:t>
-            </a:r>
-          </a:p>
-        </p:txBody>
-      </p:sp>
-      <p:sp>
-        <p:nvSpPr>
-          <p:cNvPr id="8" name="Rounded Rectangle 7"/>
+              <a:t>Production Dashboard: Double Coverage Campaign Auto-Clipper (9:16 Vertical Processing &amp; Hook Scoring).</a:t>
+            </a:r>
+          </a:p>
+        </p:txBody>
+      </p:sp>
+      <p:sp>
+        <p:nvSpPr>
+          <p:cNvPr id="9" name="Rounded Rectangle 8"/>
           <p:cNvSpPr/>
           <p:nvPr/>
         </p:nvSpPr>
         <p:spPr>
           <a:xfrm>
-            <a:off x="4389120" y="1691640"/>
-            <a:ext cx="3383280" cy="868680"/>
+            <a:off x="7132320" y="1691640"/>
+            <a:ext cx="4297680" cy="4709160"/>
           </a:xfrm>
           <a:prstGeom prst="roundRect">
             <a:avLst>
-              <a:gd name="adj" fmla="val 3000"/>
+              <a:gd name="adj" fmla="val 2000"/>
             </a:avLst>
           </a:prstGeom>
           <a:solidFill>
@@ -10844,102 +10840,26 @@
       </p:sp>
       <p:sp>
         <p:nvSpPr>
-          <p:cNvPr id="9" name="TextBox 8"/>
-          <p:cNvSpPr txBox="1"/>
-          <p:nvPr/>
-        </p:nvSpPr>
-        <p:spPr>
-          <a:xfrm>
-            <a:off x="4526280" y="1755648"/>
-            <a:ext cx="3108960" cy="731520"/>
-          </a:xfrm>
-          <a:prstGeom prst="rect">
-            <a:avLst/>
-          </a:prstGeom>
-          <a:noFill/>
-        </p:spPr>
-        <p:txBody>
-          <a:bodyPr wrap="square" lIns="0" tIns="0">
-            <a:spAutoFit/>
-          </a:bodyPr>
-          <a:lstStyle/>
-          <a:p>
-            <a:pPr>
-              <a:defRPr sz="1700" b="1">
-                <a:solidFill>
-                  <a:srgbClr val="2563EB"/>
-                </a:solidFill>
-                <a:latin typeface="Segoe UI"/>
-              </a:defRPr>
-            </a:pPr>
-            <a:r>
-              <a:rPr sz="1700" b="1">
-                <a:solidFill>
-                  <a:srgbClr val="2563EB"/>
-                </a:solidFill>
-                <a:latin typeface="Segoe UI"/>
-              </a:rPr>
-              <a:t>3x </a:t>
-            </a:r>
-            <a:r>
-              <a:rPr sz="950" b="1">
-                <a:solidFill>
-                  <a:srgbClr val="0F2437"/>
-                </a:solidFill>
-                <a:latin typeface="Segoe UI"/>
-              </a:rPr>
-              <a:t> VOLUME PRODUKSI</a:t>
-            </a:r>
-          </a:p>
-          <a:p>
-            <a:pPr algn="l">
-              <a:spcBef>
-                <a:spcPts val="0"/>
-              </a:spcBef>
-              <a:spcAft>
-                <a:spcPts val="300"/>
-              </a:spcAft>
-              <a:defRPr sz="800" b="0" i="0">
-                <a:solidFill>
-                  <a:srgbClr val="475569"/>
-                </a:solidFill>
-                <a:latin typeface="Segoe UI"/>
-              </a:defRPr>
-            </a:pPr>
-            <a:r>
-              <a:rPr sz="800" b="0" i="0">
-                <a:solidFill>
-                  <a:srgbClr val="475569"/>
-                </a:solidFill>
-                <a:latin typeface="Segoe UI"/>
-              </a:rPr>
-              <a:t>Peningkatan output klip pendek harian multi-platform.</a:t>
-            </a:r>
-          </a:p>
-        </p:txBody>
-      </p:sp>
-      <p:sp>
-        <p:nvSpPr>
           <p:cNvPr id="10" name="Rounded Rectangle 9"/>
           <p:cNvSpPr/>
           <p:nvPr/>
         </p:nvSpPr>
         <p:spPr>
           <a:xfrm>
-            <a:off x="8046720" y="1691640"/>
-            <a:ext cx="3383280" cy="868680"/>
+            <a:off x="7315200" y="1828800"/>
+            <a:ext cx="3931920" cy="749808"/>
           </a:xfrm>
           <a:prstGeom prst="roundRect">
             <a:avLst>
-              <a:gd name="adj" fmla="val 3000"/>
+              <a:gd name="adj" fmla="val 4000"/>
             </a:avLst>
           </a:prstGeom>
           <a:solidFill>
-            <a:srgbClr val="FFFFFF"/>
+            <a:srgbClr val="EFF6FF"/>
           </a:solidFill>
           <a:ln w="12700">
             <a:solidFill>
-              <a:srgbClr val="E2E8F0"/>
+              <a:srgbClr val="BFDBFE"/>
             </a:solidFill>
           </a:ln>
         </p:spPr>
@@ -10973,8 +10893,8 @@
         </p:nvSpPr>
         <p:spPr>
           <a:xfrm>
-            <a:off x="8183880" y="1755648"/>
-            <a:ext cx="3108960" cy="731520"/>
+            <a:off x="7452360" y="1901952"/>
+            <a:ext cx="3657600" cy="621792"/>
           </a:xfrm>
           <a:prstGeom prst="rect">
             <a:avLst/>
@@ -10982,36 +10902,36 @@
           <a:noFill/>
         </p:spPr>
         <p:txBody>
-          <a:bodyPr wrap="square" lIns="0" tIns="0">
+          <a:bodyPr wrap="none" lIns="0" tIns="0">
             <a:spAutoFit/>
           </a:bodyPr>
           <a:lstStyle/>
           <a:p>
             <a:pPr>
-              <a:defRPr sz="1700" b="1">
+              <a:defRPr sz="1600" b="1">
+                <a:solidFill>
+                  <a:srgbClr val="0F2437"/>
+                </a:solidFill>
+                <a:latin typeface="Segoe UI"/>
+              </a:defRPr>
+            </a:pPr>
+            <a:r>
+              <a:rPr sz="1600" b="1">
+                <a:solidFill>
+                  <a:srgbClr val="0F2437"/>
+                </a:solidFill>
+                <a:latin typeface="Segoe UI"/>
+              </a:rPr>
+              <a:t>~70%  </a:t>
+            </a:r>
+            <a:r>
+              <a:rPr sz="950" b="1">
                 <a:solidFill>
                   <a:srgbClr val="2563EB"/>
                 </a:solidFill>
                 <a:latin typeface="Segoe UI"/>
-              </a:defRPr>
-            </a:pPr>
-            <a:r>
-              <a:rPr sz="1700" b="1">
-                <a:solidFill>
-                  <a:srgbClr val="2563EB"/>
-                </a:solidFill>
-                <a:latin typeface="Segoe UI"/>
-              </a:rPr>
-              <a:t>100% </a:t>
-            </a:r>
-            <a:r>
-              <a:rPr sz="950" b="1">
-                <a:solidFill>
-                  <a:srgbClr val="0F2437"/>
-                </a:solidFill>
-                <a:latin typeface="Segoe UI"/>
-              </a:rPr>
-              <a:t> KONSISTENSI BRANDING</a:t>
+              </a:rPr>
+              <a:t>— REDUKSI TURNAROUND</a:t>
             </a:r>
           </a:p>
           <a:p>
@@ -11022,7 +10942,7 @@
               <a:spcAft>
                 <a:spcPts val="300"/>
               </a:spcAft>
-              <a:defRPr sz="800" b="0" i="0">
+              <a:defRPr sz="850" b="0" i="0">
                 <a:solidFill>
                   <a:srgbClr val="475569"/>
                 </a:solidFill>
@@ -11030,13 +10950,13 @@
               </a:defRPr>
             </a:pPr>
             <a:r>
-              <a:rPr sz="800" b="0" i="0">
+              <a:rPr sz="850" b="0" i="0">
                 <a:solidFill>
                   <a:srgbClr val="475569"/>
                 </a:solidFill>
                 <a:latin typeface="Segoe UI"/>
               </a:rPr>
-              <a:t>Automated subtitling, aspect ratio 9:16, and b-roll placement.</a:t>
+              <a:t>Penyusutan waktu dari transkrip mentah ke video</a:t>
             </a:r>
           </a:p>
         </p:txBody>
@@ -11049,20 +10969,20 @@
         </p:nvSpPr>
         <p:spPr>
           <a:xfrm>
-            <a:off x="731520" y="2697480"/>
-            <a:ext cx="3383280" cy="3703320"/>
+            <a:off x="7315200" y="2697480"/>
+            <a:ext cx="3931920" cy="749808"/>
           </a:xfrm>
           <a:prstGeom prst="roundRect">
             <a:avLst>
-              <a:gd name="adj" fmla="val 2000"/>
+              <a:gd name="adj" fmla="val 4000"/>
             </a:avLst>
           </a:prstGeom>
           <a:solidFill>
-            <a:srgbClr val="FFFFFF"/>
+            <a:srgbClr val="EFF6FF"/>
           </a:solidFill>
           <a:ln w="12700">
             <a:solidFill>
-              <a:srgbClr val="E2E8F0"/>
+              <a:srgbClr val="BFDBFE"/>
             </a:solidFill>
           </a:ln>
         </p:spPr>
@@ -11090,23 +11010,103 @@
       </p:sp>
       <p:sp>
         <p:nvSpPr>
-          <p:cNvPr id="13" name="Rectangle 12"/>
-          <p:cNvSpPr/>
-          <p:nvPr/>
-        </p:nvSpPr>
-        <p:spPr>
-          <a:xfrm>
-            <a:off x="731520" y="2697480"/>
-            <a:ext cx="3383280" cy="73152"/>
+          <p:cNvPr id="13" name="TextBox 12"/>
+          <p:cNvSpPr txBox="1"/>
+          <p:nvPr/>
+        </p:nvSpPr>
+        <p:spPr>
+          <a:xfrm>
+            <a:off x="7452360" y="2770632"/>
+            <a:ext cx="3657600" cy="621792"/>
           </a:xfrm>
           <a:prstGeom prst="rect">
             <a:avLst/>
           </a:prstGeom>
+          <a:noFill/>
+        </p:spPr>
+        <p:txBody>
+          <a:bodyPr wrap="none" lIns="0" tIns="0">
+            <a:spAutoFit/>
+          </a:bodyPr>
+          <a:lstStyle/>
+          <a:p>
+            <a:pPr>
+              <a:defRPr sz="1600" b="1">
+                <a:solidFill>
+                  <a:srgbClr val="0F2437"/>
+                </a:solidFill>
+                <a:latin typeface="Segoe UI"/>
+              </a:defRPr>
+            </a:pPr>
+            <a:r>
+              <a:rPr sz="1600" b="1">
+                <a:solidFill>
+                  <a:srgbClr val="0F2437"/>
+                </a:solidFill>
+                <a:latin typeface="Segoe UI"/>
+              </a:rPr>
+              <a:t>10/10  </a:t>
+            </a:r>
+            <a:r>
+              <a:rPr sz="950" b="1">
+                <a:solidFill>
+                  <a:srgbClr val="2563EB"/>
+                </a:solidFill>
+                <a:latin typeface="Segoe UI"/>
+              </a:rPr>
+              <a:t>— VIRAL HOOK SCORING</a:t>
+            </a:r>
+          </a:p>
+          <a:p>
+            <a:pPr algn="l">
+              <a:spcBef>
+                <a:spcPts val="0"/>
+              </a:spcBef>
+              <a:spcAft>
+                <a:spcPts val="300"/>
+              </a:spcAft>
+              <a:defRPr sz="850" b="0" i="0">
+                <a:solidFill>
+                  <a:srgbClr val="475569"/>
+                </a:solidFill>
+                <a:latin typeface="Segoe UI"/>
+              </a:defRPr>
+            </a:pPr>
+            <a:r>
+              <a:rPr sz="850" b="0" i="0">
+                <a:solidFill>
+                  <a:srgbClr val="475569"/>
+                </a:solidFill>
+                <a:latin typeface="Segoe UI"/>
+              </a:rPr>
+              <a:t>Deteksi psikologis emosi, shock &amp; virality rating</a:t>
+            </a:r>
+          </a:p>
+        </p:txBody>
+      </p:sp>
+      <p:sp>
+        <p:nvSpPr>
+          <p:cNvPr id="14" name="Rounded Rectangle 13"/>
+          <p:cNvSpPr/>
+          <p:nvPr/>
+        </p:nvSpPr>
+        <p:spPr>
+          <a:xfrm>
+            <a:off x="7315200" y="3566160"/>
+            <a:ext cx="3931920" cy="749808"/>
+          </a:xfrm>
+          <a:prstGeom prst="roundRect">
+            <a:avLst>
+              <a:gd name="adj" fmla="val 4000"/>
+            </a:avLst>
+          </a:prstGeom>
           <a:solidFill>
-            <a:srgbClr val="0EA5E9"/>
+            <a:srgbClr val="EFF6FF"/>
           </a:solidFill>
-          <a:ln>
-            <a:noFill/>
+          <a:ln w="12700">
+            <a:solidFill>
+              <a:srgbClr val="BFDBFE"/>
+            </a:solidFill>
           </a:ln>
         </p:spPr>
         <p:style>
@@ -11133,14 +11133,90 @@
       </p:sp>
       <p:sp>
         <p:nvSpPr>
-          <p:cNvPr id="14" name="TextBox 13"/>
+          <p:cNvPr id="15" name="TextBox 14"/>
           <p:cNvSpPr txBox="1"/>
           <p:nvPr/>
         </p:nvSpPr>
         <p:spPr>
           <a:xfrm>
-            <a:off x="914400" y="2862072"/>
-            <a:ext cx="3017520" cy="3429000"/>
+            <a:off x="7452360" y="3639312"/>
+            <a:ext cx="3657600" cy="621792"/>
+          </a:xfrm>
+          <a:prstGeom prst="rect">
+            <a:avLst/>
+          </a:prstGeom>
+          <a:noFill/>
+        </p:spPr>
+        <p:txBody>
+          <a:bodyPr wrap="none" lIns="0" tIns="0">
+            <a:spAutoFit/>
+          </a:bodyPr>
+          <a:lstStyle/>
+          <a:p>
+            <a:pPr>
+              <a:defRPr sz="1600" b="1">
+                <a:solidFill>
+                  <a:srgbClr val="0F2437"/>
+                </a:solidFill>
+                <a:latin typeface="Segoe UI"/>
+              </a:defRPr>
+            </a:pPr>
+            <a:r>
+              <a:rPr sz="1600" b="1">
+                <a:solidFill>
+                  <a:srgbClr val="0F2437"/>
+                </a:solidFill>
+                <a:latin typeface="Segoe UI"/>
+              </a:rPr>
+              <a:t>100%  </a:t>
+            </a:r>
+            <a:r>
+              <a:rPr sz="950" b="1">
+                <a:solidFill>
+                  <a:srgbClr val="2563EB"/>
+                </a:solidFill>
+                <a:latin typeface="Segoe UI"/>
+              </a:rPr>
+              <a:t>— 9:16 BATCH RENDERING</a:t>
+            </a:r>
+          </a:p>
+          <a:p>
+            <a:pPr algn="l">
+              <a:spcBef>
+                <a:spcPts val="0"/>
+              </a:spcBef>
+              <a:spcAft>
+                <a:spcPts val="300"/>
+              </a:spcAft>
+              <a:defRPr sz="850" b="0" i="0">
+                <a:solidFill>
+                  <a:srgbClr val="475569"/>
+                </a:solidFill>
+                <a:latin typeface="Segoe UI"/>
+              </a:defRPr>
+            </a:pPr>
+            <a:r>
+              <a:rPr sz="850" b="0" i="0">
+                <a:solidFill>
+                  <a:srgbClr val="475569"/>
+                </a:solidFill>
+                <a:latin typeface="Segoe UI"/>
+              </a:rPr>
+              <a:t>Watermark auto-applied, dynamic subtitles &amp; BGM</a:t>
+            </a:r>
+          </a:p>
+        </p:txBody>
+      </p:sp>
+      <p:sp>
+        <p:nvSpPr>
+          <p:cNvPr id="16" name="TextBox 15"/>
+          <p:cNvSpPr txBox="1"/>
+          <p:nvPr/>
+        </p:nvSpPr>
+        <p:spPr>
+          <a:xfrm>
+            <a:off x="7315200" y="4572000"/>
+            <a:ext cx="3931920" cy="1737360"/>
           </a:xfrm>
           <a:prstGeom prst="rect">
             <a:avLst/>
@@ -11158,34 +11234,9 @@
                 <a:spcPts val="0"/>
               </a:spcBef>
               <a:spcAft>
-                <a:spcPts val="100"/>
-              </a:spcAft>
-              <a:defRPr sz="900" b="1" i="0">
-                <a:solidFill>
-                  <a:srgbClr val="2563EB"/>
-                </a:solidFill>
-                <a:latin typeface="Segoe UI"/>
-              </a:defRPr>
-            </a:pPr>
-            <a:r>
-              <a:rPr sz="900" b="1" i="0">
-                <a:solidFill>
-                  <a:srgbClr val="2563EB"/>
-                </a:solidFill>
-                <a:latin typeface="Segoe UI"/>
-              </a:rPr>
-              <a:t>AGEN 01: INGESTION &amp; HOOK ANALYZER</a:t>
-            </a:r>
-          </a:p>
-          <a:p>
-            <a:pPr algn="l">
-              <a:spcBef>
-                <a:spcPts val="0"/>
-              </a:spcBef>
-              <a:spcAft>
-                <a:spcPts val="400"/>
-              </a:spcAft>
-              <a:defRPr sz="1200" b="1" i="0">
+                <a:spcPts val="300"/>
+              </a:spcAft>
+              <a:defRPr sz="1000" b="1" i="0">
                 <a:solidFill>
                   <a:srgbClr val="0F2437"/>
                 </a:solidFill>
@@ -11193,22 +11244,22 @@
               </a:defRPr>
             </a:pPr>
             <a:r>
-              <a:rPr sz="1200" b="1" i="0">
+              <a:rPr sz="1000" b="1" i="0">
                 <a:solidFill>
                   <a:srgbClr val="0F2437"/>
                 </a:solidFill>
                 <a:latin typeface="Segoe UI"/>
               </a:rPr>
-              <a:t>Content Intelligence &amp; Selection</a:t>
-            </a:r>
-          </a:p>
-          <a:p>
-            <a:pPr algn="l">
-              <a:spcBef>
-                <a:spcPts val="0"/>
-              </a:spcBef>
-              <a:spcAft>
-                <a:spcPts val="800"/>
+              <a:t>FITUR &amp; ARSITEKTUR MULTI-AGEN:</a:t>
+            </a:r>
+          </a:p>
+          <a:p>
+            <a:pPr algn="l">
+              <a:spcBef>
+                <a:spcPts val="0"/>
+              </a:spcBef>
+              <a:spcAft>
+                <a:spcPts val="300"/>
               </a:spcAft>
               <a:defRPr sz="850" b="0" i="0">
                 <a:solidFill>
@@ -11224,57 +11275,7 @@
                 </a:solidFill>
                 <a:latin typeface="Segoe UI"/>
               </a:rPr>
-              <a:t>Mengekstrak transkrip audio podcast berdurasi panjang dengan timestamp presisi. Menganalisis densitas emosi, keyword virality, dan mengidentifikasi potensi 'golden moments' 30-60 detik.</a:t>
-            </a:r>
-          </a:p>
-          <a:p>
-            <a:pPr algn="l">
-              <a:spcBef>
-                <a:spcPts val="0"/>
-              </a:spcBef>
-              <a:spcAft>
-                <a:spcPts val="200"/>
-              </a:spcAft>
-              <a:defRPr sz="800" b="1" i="0">
-                <a:solidFill>
-                  <a:srgbClr val="1E3A8A"/>
-                </a:solidFill>
-                <a:latin typeface="Segoe UI"/>
-              </a:defRPr>
-            </a:pPr>
-            <a:r>
-              <a:rPr sz="800" b="1" i="0">
-                <a:solidFill>
-                  <a:srgbClr val="1E3A8A"/>
-                </a:solidFill>
-                <a:latin typeface="Segoe UI"/>
-              </a:rPr>
-              <a:t>▸ Input: Audio/Video Podcast Mentah + Metadata</a:t>
-            </a:r>
-          </a:p>
-          <a:p>
-            <a:pPr algn="l">
-              <a:spcBef>
-                <a:spcPts val="0"/>
-              </a:spcBef>
-              <a:spcAft>
-                <a:spcPts val="800"/>
-              </a:spcAft>
-              <a:defRPr sz="800" b="1" i="0">
-                <a:solidFill>
-                  <a:srgbClr val="059669"/>
-                </a:solidFill>
-                <a:latin typeface="Segoe UI"/>
-              </a:defRPr>
-            </a:pPr>
-            <a:r>
-              <a:rPr sz="800" b="1" i="0">
-                <a:solidFill>
-                  <a:srgbClr val="059669"/>
-                </a:solidFill>
-                <a:latin typeface="Segoe UI"/>
-              </a:rPr>
-              <a:t>▸ Output: Timestamped Golden Segments &amp; Hook Score</a:t>
+              <a:t>• Curated Viral Moments: Deteksi otomatis hook 3 detik pembuka, segmentasi timestamp akurat, dan scoring virality 10/10.</a:t>
             </a:r>
           </a:p>
           <a:p>
@@ -11285,194 +11286,6 @@
               <a:spcAft>
                 <a:spcPts val="300"/>
               </a:spcAft>
-              <a:defRPr sz="800" b="0" i="1">
-                <a:solidFill>
-                  <a:srgbClr val="475569"/>
-                </a:solidFill>
-                <a:latin typeface="Segoe UI"/>
-              </a:defRPr>
-            </a:pPr>
-            <a:r>
-              <a:rPr sz="800" b="0" i="1">
-                <a:solidFill>
-                  <a:srgbClr val="475569"/>
-                </a:solidFill>
-                <a:latin typeface="Segoe UI"/>
-              </a:rPr>
-              <a:t>Stack: Python, Speech-to-Text API, Semantic Scoring</a:t>
-            </a:r>
-          </a:p>
-        </p:txBody>
-      </p:sp>
-      <p:sp>
-        <p:nvSpPr>
-          <p:cNvPr id="15" name="Rounded Rectangle 14"/>
-          <p:cNvSpPr/>
-          <p:nvPr/>
-        </p:nvSpPr>
-        <p:spPr>
-          <a:xfrm>
-            <a:off x="4389120" y="2697480"/>
-            <a:ext cx="3383280" cy="3703320"/>
-          </a:xfrm>
-          <a:prstGeom prst="roundRect">
-            <a:avLst>
-              <a:gd name="adj" fmla="val 2000"/>
-            </a:avLst>
-          </a:prstGeom>
-          <a:solidFill>
-            <a:srgbClr val="FFFFFF"/>
-          </a:solidFill>
-          <a:ln w="12700">
-            <a:solidFill>
-              <a:srgbClr val="E2E8F0"/>
-            </a:solidFill>
-          </a:ln>
-        </p:spPr>
-        <p:style>
-          <a:lnRef idx="1">
-            <a:schemeClr val="accent1"/>
-          </a:lnRef>
-          <a:fillRef idx="3">
-            <a:schemeClr val="accent1"/>
-          </a:fillRef>
-          <a:effectRef idx="2">
-            <a:schemeClr val="accent1"/>
-          </a:effectRef>
-          <a:fontRef idx="minor">
-            <a:schemeClr val="lt1"/>
-          </a:fontRef>
-        </p:style>
-        <p:txBody>
-          <a:bodyPr rtlCol="0" anchor="ctr"/>
-          <a:lstStyle/>
-          <a:p>
-            <a:pPr algn="ctr"/>
-          </a:p>
-        </p:txBody>
-      </p:sp>
-      <p:sp>
-        <p:nvSpPr>
-          <p:cNvPr id="16" name="Rectangle 15"/>
-          <p:cNvSpPr/>
-          <p:nvPr/>
-        </p:nvSpPr>
-        <p:spPr>
-          <a:xfrm>
-            <a:off x="4389120" y="2697480"/>
-            <a:ext cx="3383280" cy="73152"/>
-          </a:xfrm>
-          <a:prstGeom prst="rect">
-            <a:avLst/>
-          </a:prstGeom>
-          <a:solidFill>
-            <a:srgbClr val="2563EB"/>
-          </a:solidFill>
-          <a:ln>
-            <a:noFill/>
-          </a:ln>
-        </p:spPr>
-        <p:style>
-          <a:lnRef idx="1">
-            <a:schemeClr val="accent1"/>
-          </a:lnRef>
-          <a:fillRef idx="3">
-            <a:schemeClr val="accent1"/>
-          </a:fillRef>
-          <a:effectRef idx="2">
-            <a:schemeClr val="accent1"/>
-          </a:effectRef>
-          <a:fontRef idx="minor">
-            <a:schemeClr val="lt1"/>
-          </a:fontRef>
-        </p:style>
-        <p:txBody>
-          <a:bodyPr rtlCol="0" anchor="ctr"/>
-          <a:lstStyle/>
-          <a:p>
-            <a:pPr algn="ctr"/>
-          </a:p>
-        </p:txBody>
-      </p:sp>
-      <p:sp>
-        <p:nvSpPr>
-          <p:cNvPr id="17" name="TextBox 16"/>
-          <p:cNvSpPr txBox="1"/>
-          <p:nvPr/>
-        </p:nvSpPr>
-        <p:spPr>
-          <a:xfrm>
-            <a:off x="4572000" y="2862072"/>
-            <a:ext cx="3017520" cy="3429000"/>
-          </a:xfrm>
-          <a:prstGeom prst="rect">
-            <a:avLst/>
-          </a:prstGeom>
-          <a:noFill/>
-        </p:spPr>
-        <p:txBody>
-          <a:bodyPr wrap="square" lIns="0" tIns="0">
-            <a:spAutoFit/>
-          </a:bodyPr>
-          <a:lstStyle/>
-          <a:p>
-            <a:pPr algn="l">
-              <a:spcBef>
-                <a:spcPts val="0"/>
-              </a:spcBef>
-              <a:spcAft>
-                <a:spcPts val="100"/>
-              </a:spcAft>
-              <a:defRPr sz="900" b="1" i="0">
-                <a:solidFill>
-                  <a:srgbClr val="2563EB"/>
-                </a:solidFill>
-                <a:latin typeface="Segoe UI"/>
-              </a:defRPr>
-            </a:pPr>
-            <a:r>
-              <a:rPr sz="900" b="1" i="0">
-                <a:solidFill>
-                  <a:srgbClr val="2563EB"/>
-                </a:solidFill>
-                <a:latin typeface="Segoe UI"/>
-              </a:rPr>
-              <a:t>AGEN 02: ADAPTATION &amp; SCRIPT SYNTHESIS</a:t>
-            </a:r>
-          </a:p>
-          <a:p>
-            <a:pPr algn="l">
-              <a:spcBef>
-                <a:spcPts val="0"/>
-              </a:spcBef>
-              <a:spcAft>
-                <a:spcPts val="400"/>
-              </a:spcAft>
-              <a:defRPr sz="1200" b="1" i="0">
-                <a:solidFill>
-                  <a:srgbClr val="0F2437"/>
-                </a:solidFill>
-                <a:latin typeface="Segoe UI"/>
-              </a:defRPr>
-            </a:pPr>
-            <a:r>
-              <a:rPr sz="1200" b="1" i="0">
-                <a:solidFill>
-                  <a:srgbClr val="0F2437"/>
-                </a:solidFill>
-                <a:latin typeface="Segoe UI"/>
-              </a:rPr>
-              <a:t>Narrative Structuring &amp; Pacing</a:t>
-            </a:r>
-          </a:p>
-          <a:p>
-            <a:pPr algn="l">
-              <a:spcBef>
-                <a:spcPts val="0"/>
-              </a:spcBef>
-              <a:spcAft>
-                <a:spcPts val="800"/>
-              </a:spcAft>
               <a:defRPr sz="850" b="0" i="0">
                 <a:solidFill>
                   <a:srgbClr val="0F172A"/>
@@ -11487,57 +11300,7 @@
                 </a:solidFill>
                 <a:latin typeface="Segoe UI"/>
               </a:rPr>
-              <a:t>Mengolah transkrip mentah menjadi format vertical short-form (9:16). Menambahkan formula hook 3 detik pembuka, teks ringkas berdaya pikat tinggi, serta instruksi transisi visual.</a:t>
-            </a:r>
-          </a:p>
-          <a:p>
-            <a:pPr algn="l">
-              <a:spcBef>
-                <a:spcPts val="0"/>
-              </a:spcBef>
-              <a:spcAft>
-                <a:spcPts val="200"/>
-              </a:spcAft>
-              <a:defRPr sz="800" b="1" i="0">
-                <a:solidFill>
-                  <a:srgbClr val="1E3A8A"/>
-                </a:solidFill>
-                <a:latin typeface="Segoe UI"/>
-              </a:defRPr>
-            </a:pPr>
-            <a:r>
-              <a:rPr sz="800" b="1" i="0">
-                <a:solidFill>
-                  <a:srgbClr val="1E3A8A"/>
-                </a:solidFill>
-                <a:latin typeface="Segoe UI"/>
-              </a:rPr>
-              <a:t>▸ Input: Golden Segments Transcripts</a:t>
-            </a:r>
-          </a:p>
-          <a:p>
-            <a:pPr algn="l">
-              <a:spcBef>
-                <a:spcPts val="0"/>
-              </a:spcBef>
-              <a:spcAft>
-                <a:spcPts val="800"/>
-              </a:spcAft>
-              <a:defRPr sz="800" b="1" i="0">
-                <a:solidFill>
-                  <a:srgbClr val="059669"/>
-                </a:solidFill>
-                <a:latin typeface="Segoe UI"/>
-              </a:defRPr>
-            </a:pPr>
-            <a:r>
-              <a:rPr sz="800" b="1" i="0">
-                <a:solidFill>
-                  <a:srgbClr val="059669"/>
-                </a:solidFill>
-                <a:latin typeface="Segoe UI"/>
-              </a:rPr>
-              <a:t>▸ Output: 9:16 Structured Script + B-Roll Prompts</a:t>
+              <a:t>• Programmatic 9:16 Center Fill: Rendering batch otomatis via script CapCut &amp; engine FFmpeg dengan auto-framing pembicara.</a:t>
             </a:r>
           </a:p>
           <a:p>
@@ -11548,194 +11311,6 @@
               <a:spcAft>
                 <a:spcPts val="300"/>
               </a:spcAft>
-              <a:defRPr sz="800" b="0" i="1">
-                <a:solidFill>
-                  <a:srgbClr val="475569"/>
-                </a:solidFill>
-                <a:latin typeface="Segoe UI"/>
-              </a:defRPr>
-            </a:pPr>
-            <a:r>
-              <a:rPr sz="800" b="0" i="1">
-                <a:solidFill>
-                  <a:srgbClr val="475569"/>
-                </a:solidFill>
-                <a:latin typeface="Segoe UI"/>
-              </a:rPr>
-              <a:t>Stack: Google Antigravity Multi-agent, Prompting</a:t>
-            </a:r>
-          </a:p>
-        </p:txBody>
-      </p:sp>
-      <p:sp>
-        <p:nvSpPr>
-          <p:cNvPr id="18" name="Rounded Rectangle 17"/>
-          <p:cNvSpPr/>
-          <p:nvPr/>
-        </p:nvSpPr>
-        <p:spPr>
-          <a:xfrm>
-            <a:off x="8046720" y="2697480"/>
-            <a:ext cx="3383280" cy="3703320"/>
-          </a:xfrm>
-          <a:prstGeom prst="roundRect">
-            <a:avLst>
-              <a:gd name="adj" fmla="val 2000"/>
-            </a:avLst>
-          </a:prstGeom>
-          <a:solidFill>
-            <a:srgbClr val="FFFFFF"/>
-          </a:solidFill>
-          <a:ln w="12700">
-            <a:solidFill>
-              <a:srgbClr val="E2E8F0"/>
-            </a:solidFill>
-          </a:ln>
-        </p:spPr>
-        <p:style>
-          <a:lnRef idx="1">
-            <a:schemeClr val="accent1"/>
-          </a:lnRef>
-          <a:fillRef idx="3">
-            <a:schemeClr val="accent1"/>
-          </a:fillRef>
-          <a:effectRef idx="2">
-            <a:schemeClr val="accent1"/>
-          </a:effectRef>
-          <a:fontRef idx="minor">
-            <a:schemeClr val="lt1"/>
-          </a:fontRef>
-        </p:style>
-        <p:txBody>
-          <a:bodyPr rtlCol="0" anchor="ctr"/>
-          <a:lstStyle/>
-          <a:p>
-            <a:pPr algn="ctr"/>
-          </a:p>
-        </p:txBody>
-      </p:sp>
-      <p:sp>
-        <p:nvSpPr>
-          <p:cNvPr id="19" name="Rectangle 18"/>
-          <p:cNvSpPr/>
-          <p:nvPr/>
-        </p:nvSpPr>
-        <p:spPr>
-          <a:xfrm>
-            <a:off x="8046720" y="2697480"/>
-            <a:ext cx="3383280" cy="73152"/>
-          </a:xfrm>
-          <a:prstGeom prst="rect">
-            <a:avLst/>
-          </a:prstGeom>
-          <a:solidFill>
-            <a:srgbClr val="0F2437"/>
-          </a:solidFill>
-          <a:ln>
-            <a:noFill/>
-          </a:ln>
-        </p:spPr>
-        <p:style>
-          <a:lnRef idx="1">
-            <a:schemeClr val="accent1"/>
-          </a:lnRef>
-          <a:fillRef idx="3">
-            <a:schemeClr val="accent1"/>
-          </a:fillRef>
-          <a:effectRef idx="2">
-            <a:schemeClr val="accent1"/>
-          </a:effectRef>
-          <a:fontRef idx="minor">
-            <a:schemeClr val="lt1"/>
-          </a:fontRef>
-        </p:style>
-        <p:txBody>
-          <a:bodyPr rtlCol="0" anchor="ctr"/>
-          <a:lstStyle/>
-          <a:p>
-            <a:pPr algn="ctr"/>
-          </a:p>
-        </p:txBody>
-      </p:sp>
-      <p:sp>
-        <p:nvSpPr>
-          <p:cNvPr id="20" name="TextBox 19"/>
-          <p:cNvSpPr txBox="1"/>
-          <p:nvPr/>
-        </p:nvSpPr>
-        <p:spPr>
-          <a:xfrm>
-            <a:off x="8229600" y="2862072"/>
-            <a:ext cx="3017520" cy="3429000"/>
-          </a:xfrm>
-          <a:prstGeom prst="rect">
-            <a:avLst/>
-          </a:prstGeom>
-          <a:noFill/>
-        </p:spPr>
-        <p:txBody>
-          <a:bodyPr wrap="square" lIns="0" tIns="0">
-            <a:spAutoFit/>
-          </a:bodyPr>
-          <a:lstStyle/>
-          <a:p>
-            <a:pPr algn="l">
-              <a:spcBef>
-                <a:spcPts val="0"/>
-              </a:spcBef>
-              <a:spcAft>
-                <a:spcPts val="100"/>
-              </a:spcAft>
-              <a:defRPr sz="900" b="1" i="0">
-                <a:solidFill>
-                  <a:srgbClr val="2563EB"/>
-                </a:solidFill>
-                <a:latin typeface="Segoe UI"/>
-              </a:defRPr>
-            </a:pPr>
-            <a:r>
-              <a:rPr sz="900" b="1" i="0">
-                <a:solidFill>
-                  <a:srgbClr val="2563EB"/>
-                </a:solidFill>
-                <a:latin typeface="Segoe UI"/>
-              </a:rPr>
-              <a:t>AGEN 03: PROGRAMMATIC VIDEO ASSEMBLER</a:t>
-            </a:r>
-          </a:p>
-          <a:p>
-            <a:pPr algn="l">
-              <a:spcBef>
-                <a:spcPts val="0"/>
-              </a:spcBef>
-              <a:spcAft>
-                <a:spcPts val="400"/>
-              </a:spcAft>
-              <a:defRPr sz="1200" b="1" i="0">
-                <a:solidFill>
-                  <a:srgbClr val="0F2437"/>
-                </a:solidFill>
-                <a:latin typeface="Segoe UI"/>
-              </a:defRPr>
-            </a:pPr>
-            <a:r>
-              <a:rPr sz="1200" b="1" i="0">
-                <a:solidFill>
-                  <a:srgbClr val="0F2437"/>
-                </a:solidFill>
-                <a:latin typeface="Segoe UI"/>
-              </a:rPr>
-              <a:t>Automated Editing Execution</a:t>
-            </a:r>
-          </a:p>
-          <a:p>
-            <a:pPr algn="l">
-              <a:spcBef>
-                <a:spcPts val="0"/>
-              </a:spcBef>
-              <a:spcAft>
-                <a:spcPts val="800"/>
-              </a:spcAft>
               <a:defRPr sz="850" b="0" i="0">
                 <a:solidFill>
                   <a:srgbClr val="0F172A"/>
@@ -11750,82 +11325,7 @@
                 </a:solidFill>
                 <a:latin typeface="Segoe UI"/>
               </a:rPr>
-              <a:t>Mengeksekusi otomasi editing melalui script CapCut &amp; FFmpeg. Menghasilkan automated dynamic subtitles, visual sound effects, auto-framing pembicara, dan ekspor batch resolusi tinggi.</a:t>
-            </a:r>
-          </a:p>
-          <a:p>
-            <a:pPr algn="l">
-              <a:spcBef>
-                <a:spcPts val="0"/>
-              </a:spcBef>
-              <a:spcAft>
-                <a:spcPts val="200"/>
-              </a:spcAft>
-              <a:defRPr sz="800" b="1" i="0">
-                <a:solidFill>
-                  <a:srgbClr val="1E3A8A"/>
-                </a:solidFill>
-                <a:latin typeface="Segoe UI"/>
-              </a:defRPr>
-            </a:pPr>
-            <a:r>
-              <a:rPr sz="800" b="1" i="0">
-                <a:solidFill>
-                  <a:srgbClr val="1E3A8A"/>
-                </a:solidFill>
-                <a:latin typeface="Segoe UI"/>
-              </a:rPr>
-              <a:t>▸ Input: Structured Script + Timeline Directives</a:t>
-            </a:r>
-          </a:p>
-          <a:p>
-            <a:pPr algn="l">
-              <a:spcBef>
-                <a:spcPts val="0"/>
-              </a:spcBef>
-              <a:spcAft>
-                <a:spcPts val="800"/>
-              </a:spcAft>
-              <a:defRPr sz="800" b="1" i="0">
-                <a:solidFill>
-                  <a:srgbClr val="059669"/>
-                </a:solidFill>
-                <a:latin typeface="Segoe UI"/>
-              </a:defRPr>
-            </a:pPr>
-            <a:r>
-              <a:rPr sz="800" b="1" i="0">
-                <a:solidFill>
-                  <a:srgbClr val="059669"/>
-                </a:solidFill>
-                <a:latin typeface="Segoe UI"/>
-              </a:rPr>
-              <a:t>▸ Output: Final 1080x1920 MP4 Ready-to-Publish</a:t>
-            </a:r>
-          </a:p>
-          <a:p>
-            <a:pPr algn="l">
-              <a:spcBef>
-                <a:spcPts val="0"/>
-              </a:spcBef>
-              <a:spcAft>
-                <a:spcPts val="300"/>
-              </a:spcAft>
-              <a:defRPr sz="800" b="0" i="1">
-                <a:solidFill>
-                  <a:srgbClr val="475569"/>
-                </a:solidFill>
-                <a:latin typeface="Segoe UI"/>
-              </a:defRPr>
-            </a:pPr>
-            <a:r>
-              <a:rPr sz="800" b="0" i="1">
-                <a:solidFill>
-                  <a:srgbClr val="475569"/>
-                </a:solidFill>
-                <a:latin typeface="Segoe UI"/>
-              </a:rPr>
-              <a:t>Stack: FFmpeg Engine, CapCut API / Scripting</a:t>
+              <a:t>• Whop Content Rewards Ready: Dilengkapi 30-min tracker checklist, pemilihan BGM ambient viral, dan vault klip siap publish.</a:t>
             </a:r>
           </a:p>
         </p:txBody>

</xml_diff>